<commit_message>
Update Intro To SQL Stored Procedures.pptx
</commit_message>
<xml_diff>
--- a/SQL/Intro To SQL Stored Procedures.pptx
+++ b/SQL/Intro To SQL Stored Procedures.pptx
@@ -9,21 +9,22 @@
     <p:sldId id="275" r:id="rId3"/>
     <p:sldId id="320" r:id="rId4"/>
     <p:sldId id="319" r:id="rId5"/>
-    <p:sldId id="276" r:id="rId6"/>
-    <p:sldId id="321" r:id="rId7"/>
-    <p:sldId id="334" r:id="rId8"/>
-    <p:sldId id="322" r:id="rId9"/>
-    <p:sldId id="323" r:id="rId10"/>
-    <p:sldId id="335" r:id="rId11"/>
-    <p:sldId id="336" r:id="rId12"/>
-    <p:sldId id="337" r:id="rId13"/>
-    <p:sldId id="277" r:id="rId14"/>
-    <p:sldId id="312" r:id="rId15"/>
-    <p:sldId id="291" r:id="rId16"/>
-    <p:sldId id="313" r:id="rId17"/>
-    <p:sldId id="333" r:id="rId18"/>
-    <p:sldId id="279" r:id="rId19"/>
-    <p:sldId id="266" r:id="rId20"/>
+    <p:sldId id="338" r:id="rId6"/>
+    <p:sldId id="276" r:id="rId7"/>
+    <p:sldId id="321" r:id="rId8"/>
+    <p:sldId id="334" r:id="rId9"/>
+    <p:sldId id="322" r:id="rId10"/>
+    <p:sldId id="323" r:id="rId11"/>
+    <p:sldId id="335" r:id="rId12"/>
+    <p:sldId id="336" r:id="rId13"/>
+    <p:sldId id="337" r:id="rId14"/>
+    <p:sldId id="277" r:id="rId15"/>
+    <p:sldId id="312" r:id="rId16"/>
+    <p:sldId id="291" r:id="rId17"/>
+    <p:sldId id="313" r:id="rId18"/>
+    <p:sldId id="333" r:id="rId19"/>
+    <p:sldId id="279" r:id="rId20"/>
+    <p:sldId id="266" r:id="rId21"/>
   </p:sldIdLst>
   <p:sldSz cx="12192000" cy="6858000"/>
   <p:notesSz cx="6858000" cy="9144000"/>
@@ -277,7 +278,7 @@
           <a:p>
             <a:fld id="{046598D6-C04D-9446-A58F-36E01C46C344}" type="datetimeFigureOut">
               <a:rPr lang="en-US" smtClean="0"/>
-              <a:t>9/6/26</a:t>
+              <a:t>9/9/26</a:t>
             </a:fld>
             <a:endParaRPr lang="en-US"/>
           </a:p>
@@ -475,7 +476,7 @@
           <a:p>
             <a:fld id="{046598D6-C04D-9446-A58F-36E01C46C344}" type="datetimeFigureOut">
               <a:rPr lang="en-US" smtClean="0"/>
-              <a:t>9/6/26</a:t>
+              <a:t>9/9/26</a:t>
             </a:fld>
             <a:endParaRPr lang="en-US"/>
           </a:p>
@@ -683,7 +684,7 @@
           <a:p>
             <a:fld id="{046598D6-C04D-9446-A58F-36E01C46C344}" type="datetimeFigureOut">
               <a:rPr lang="en-US" smtClean="0"/>
-              <a:t>9/6/26</a:t>
+              <a:t>9/9/26</a:t>
             </a:fld>
             <a:endParaRPr lang="en-US"/>
           </a:p>
@@ -881,7 +882,7 @@
           <a:p>
             <a:fld id="{046598D6-C04D-9446-A58F-36E01C46C344}" type="datetimeFigureOut">
               <a:rPr lang="en-US" smtClean="0"/>
-              <a:t>9/6/26</a:t>
+              <a:t>9/9/26</a:t>
             </a:fld>
             <a:endParaRPr lang="en-US"/>
           </a:p>
@@ -1156,7 +1157,7 @@
           <a:p>
             <a:fld id="{046598D6-C04D-9446-A58F-36E01C46C344}" type="datetimeFigureOut">
               <a:rPr lang="en-US" smtClean="0"/>
-              <a:t>9/6/26</a:t>
+              <a:t>9/9/26</a:t>
             </a:fld>
             <a:endParaRPr lang="en-US"/>
           </a:p>
@@ -1421,7 +1422,7 @@
           <a:p>
             <a:fld id="{046598D6-C04D-9446-A58F-36E01C46C344}" type="datetimeFigureOut">
               <a:rPr lang="en-US" smtClean="0"/>
-              <a:t>9/6/26</a:t>
+              <a:t>9/9/26</a:t>
             </a:fld>
             <a:endParaRPr lang="en-US"/>
           </a:p>
@@ -1833,7 +1834,7 @@
           <a:p>
             <a:fld id="{046598D6-C04D-9446-A58F-36E01C46C344}" type="datetimeFigureOut">
               <a:rPr lang="en-US" smtClean="0"/>
-              <a:t>9/6/26</a:t>
+              <a:t>9/9/26</a:t>
             </a:fld>
             <a:endParaRPr lang="en-US"/>
           </a:p>
@@ -1974,7 +1975,7 @@
           <a:p>
             <a:fld id="{046598D6-C04D-9446-A58F-36E01C46C344}" type="datetimeFigureOut">
               <a:rPr lang="en-US" smtClean="0"/>
-              <a:t>9/6/26</a:t>
+              <a:t>9/9/26</a:t>
             </a:fld>
             <a:endParaRPr lang="en-US"/>
           </a:p>
@@ -2087,7 +2088,7 @@
           <a:p>
             <a:fld id="{046598D6-C04D-9446-A58F-36E01C46C344}" type="datetimeFigureOut">
               <a:rPr lang="en-US" smtClean="0"/>
-              <a:t>9/6/26</a:t>
+              <a:t>9/9/26</a:t>
             </a:fld>
             <a:endParaRPr lang="en-US"/>
           </a:p>
@@ -2398,7 +2399,7 @@
           <a:p>
             <a:fld id="{046598D6-C04D-9446-A58F-36E01C46C344}" type="datetimeFigureOut">
               <a:rPr lang="en-US" smtClean="0"/>
-              <a:t>9/6/26</a:t>
+              <a:t>9/9/26</a:t>
             </a:fld>
             <a:endParaRPr lang="en-US"/>
           </a:p>
@@ -2686,7 +2687,7 @@
           <a:p>
             <a:fld id="{046598D6-C04D-9446-A58F-36E01C46C344}" type="datetimeFigureOut">
               <a:rPr lang="en-US" smtClean="0"/>
-              <a:t>9/6/26</a:t>
+              <a:t>9/9/26</a:t>
             </a:fld>
             <a:endParaRPr lang="en-US"/>
           </a:p>
@@ -2927,7 +2928,7 @@
           <a:p>
             <a:fld id="{046598D6-C04D-9446-A58F-36E01C46C344}" type="datetimeFigureOut">
               <a:rPr lang="en-US" smtClean="0"/>
-              <a:t>9/6/26</a:t>
+              <a:t>9/9/26</a:t>
             </a:fld>
             <a:endParaRPr lang="en-US"/>
           </a:p>
@@ -3408,10 +3409,9 @@
           <a:lstStyle/>
           <a:p>
             <a:r>
-              <a:rPr lang="en-US"/>
-              <a:t>September 6, 2026</a:t>
-            </a:r>
-            <a:endParaRPr lang="en-US" dirty="0"/>
+              <a:rPr lang="en-US" dirty="0"/>
+              <a:t>September 9, 2026</a:t>
+            </a:r>
           </a:p>
           <a:p>
             <a:r>
@@ -3456,6 +3456,100 @@
           <p:cNvPr id="2" name="Title 1">
             <a:extLst>
               <a:ext uri="{FF2B5EF4-FFF2-40B4-BE49-F238E27FC236}">
+                <a16:creationId xmlns:a16="http://schemas.microsoft.com/office/drawing/2014/main" id="{584F92C9-1DAE-04AF-D8A8-4890FC19A0FE}"/>
+              </a:ext>
+            </a:extLst>
+          </p:cNvPr>
+          <p:cNvSpPr>
+            <a:spLocks noGrp="1"/>
+          </p:cNvSpPr>
+          <p:nvPr>
+            <p:ph type="title"/>
+          </p:nvPr>
+        </p:nvSpPr>
+        <p:spPr/>
+        <p:txBody>
+          <a:bodyPr/>
+          <a:lstStyle/>
+          <a:p>
+            <a:r>
+              <a:rPr lang="en-US" b="0" i="0" dirty="0">
+                <a:effectLst/>
+                <a:highlight>
+                  <a:srgbClr val="FFFFFF"/>
+                </a:highlight>
+                <a:latin typeface="Roboto" panose="02000000000000000000" pitchFamily="2" charset="0"/>
+              </a:rPr>
+              <a:t>Service layer:</a:t>
+            </a:r>
+            <a:endParaRPr lang="en-US" dirty="0"/>
+          </a:p>
+        </p:txBody>
+      </p:sp>
+      <p:pic>
+        <p:nvPicPr>
+          <p:cNvPr id="5" name="Content Placeholder 4" descr="A computer screen shot of text&#10;&#10;AI-generated content may be incorrect.">
+            <a:extLst>
+              <a:ext uri="{FF2B5EF4-FFF2-40B4-BE49-F238E27FC236}">
+                <a16:creationId xmlns:a16="http://schemas.microsoft.com/office/drawing/2014/main" id="{BA4A2944-7BEA-BF5E-C4C4-013128DE48B0}"/>
+              </a:ext>
+            </a:extLst>
+          </p:cNvPr>
+          <p:cNvPicPr>
+            <a:picLocks noGrp="1" noChangeAspect="1"/>
+          </p:cNvPicPr>
+          <p:nvPr>
+            <p:ph idx="1"/>
+          </p:nvPr>
+        </p:nvPicPr>
+        <p:blipFill>
+          <a:blip r:embed="rId2"/>
+          <a:stretch>
+            <a:fillRect/>
+          </a:stretch>
+        </p:blipFill>
+        <p:spPr>
+          <a:xfrm>
+            <a:off x="2870200" y="1981994"/>
+            <a:ext cx="6451600" cy="4038600"/>
+          </a:xfrm>
+        </p:spPr>
+      </p:pic>
+    </p:spTree>
+    <p:extLst>
+      <p:ext uri="{BB962C8B-B14F-4D97-AF65-F5344CB8AC3E}">
+        <p14:creationId xmlns:p14="http://schemas.microsoft.com/office/powerpoint/2010/main" val="2099651633"/>
+      </p:ext>
+    </p:extLst>
+  </p:cSld>
+  <p:clrMapOvr>
+    <a:masterClrMapping/>
+  </p:clrMapOvr>
+</p:sld>
+</file>
+
+<file path=ppt/slides/slide11.xml><?xml version="1.0" encoding="utf-8"?>
+<p:sld xmlns:a="http://schemas.openxmlformats.org/drawingml/2006/main" xmlns:r="http://schemas.openxmlformats.org/officeDocument/2006/relationships" xmlns:p="http://schemas.openxmlformats.org/presentationml/2006/main">
+  <p:cSld>
+    <p:spTree>
+      <p:nvGrpSpPr>
+        <p:cNvPr id="1" name=""/>
+        <p:cNvGrpSpPr/>
+        <p:nvPr/>
+      </p:nvGrpSpPr>
+      <p:grpSpPr>
+        <a:xfrm>
+          <a:off x="0" y="0"/>
+          <a:ext cx="0" cy="0"/>
+          <a:chOff x="0" y="0"/>
+          <a:chExt cx="0" cy="0"/>
+        </a:xfrm>
+      </p:grpSpPr>
+      <p:sp>
+        <p:nvSpPr>
+          <p:cNvPr id="2" name="Title 1">
+            <a:extLst>
+              <a:ext uri="{FF2B5EF4-FFF2-40B4-BE49-F238E27FC236}">
                 <a16:creationId xmlns:a16="http://schemas.microsoft.com/office/drawing/2014/main" id="{17B1B886-51DF-7269-4588-BBDAE35C2A2D}"/>
               </a:ext>
             </a:extLst>
@@ -3521,7 +3615,7 @@
 </p:sld>
 </file>
 
-<file path=ppt/slides/slide11.xml><?xml version="1.0" encoding="utf-8"?>
+<file path=ppt/slides/slide12.xml><?xml version="1.0" encoding="utf-8"?>
 <p:sld xmlns:a="http://schemas.openxmlformats.org/drawingml/2006/main" xmlns:r="http://schemas.openxmlformats.org/officeDocument/2006/relationships" xmlns:p="http://schemas.openxmlformats.org/presentationml/2006/main">
   <p:cSld>
     <p:spTree>
@@ -3613,7 +3707,7 @@
 </p:sld>
 </file>
 
-<file path=ppt/slides/slide12.xml><?xml version="1.0" encoding="utf-8"?>
+<file path=ppt/slides/slide13.xml><?xml version="1.0" encoding="utf-8"?>
 <p:sld xmlns:a="http://schemas.openxmlformats.org/drawingml/2006/main" xmlns:r="http://schemas.openxmlformats.org/officeDocument/2006/relationships" xmlns:p="http://schemas.openxmlformats.org/presentationml/2006/main">
   <p:cSld>
     <p:spTree>
@@ -3705,7 +3799,7 @@
 </p:sld>
 </file>
 
-<file path=ppt/slides/slide13.xml><?xml version="1.0" encoding="utf-8"?>
+<file path=ppt/slides/slide14.xml><?xml version="1.0" encoding="utf-8"?>
 <p:sld xmlns:a="http://schemas.openxmlformats.org/drawingml/2006/main" xmlns:r="http://schemas.openxmlformats.org/officeDocument/2006/relationships" xmlns:p="http://schemas.openxmlformats.org/presentationml/2006/main">
   <p:cSld>
     <p:spTree>
@@ -3795,114 +3889,6 @@
 </p:sld>
 </file>
 
-<file path=ppt/slides/slide14.xml><?xml version="1.0" encoding="utf-8"?>
-<p:sld xmlns:a="http://schemas.openxmlformats.org/drawingml/2006/main" xmlns:r="http://schemas.openxmlformats.org/officeDocument/2006/relationships" xmlns:p="http://schemas.openxmlformats.org/presentationml/2006/main">
-  <p:cSld>
-    <p:spTree>
-      <p:nvGrpSpPr>
-        <p:cNvPr id="1" name=""/>
-        <p:cNvGrpSpPr/>
-        <p:nvPr/>
-      </p:nvGrpSpPr>
-      <p:grpSpPr>
-        <a:xfrm>
-          <a:off x="0" y="0"/>
-          <a:ext cx="0" cy="0"/>
-          <a:chOff x="0" y="0"/>
-          <a:chExt cx="0" cy="0"/>
-        </a:xfrm>
-      </p:grpSpPr>
-      <p:sp>
-        <p:nvSpPr>
-          <p:cNvPr id="2" name="Title 1">
-            <a:extLst>
-              <a:ext uri="{FF2B5EF4-FFF2-40B4-BE49-F238E27FC236}">
-                <a16:creationId xmlns:a16="http://schemas.microsoft.com/office/drawing/2014/main" id="{8CBFCD5F-DE8E-6A7C-9FEF-6806621B69CE}"/>
-              </a:ext>
-            </a:extLst>
-          </p:cNvPr>
-          <p:cNvSpPr>
-            <a:spLocks noGrp="1"/>
-          </p:cNvSpPr>
-          <p:nvPr>
-            <p:ph type="title"/>
-          </p:nvPr>
-        </p:nvSpPr>
-        <p:spPr/>
-        <p:txBody>
-          <a:bodyPr/>
-          <a:lstStyle/>
-          <a:p>
-            <a:r>
-              <a:rPr lang="en-US" b="0" i="0" dirty="0">
-                <a:effectLst/>
-                <a:highlight>
-                  <a:srgbClr val="FFFFFF"/>
-                </a:highlight>
-                <a:latin typeface="Roboto" panose="02000000000000000000" pitchFamily="2" charset="0"/>
-              </a:rPr>
-              <a:t>Data Validation</a:t>
-            </a:r>
-            <a:endParaRPr lang="en-US" dirty="0"/>
-          </a:p>
-        </p:txBody>
-      </p:sp>
-      <p:sp>
-        <p:nvSpPr>
-          <p:cNvPr id="3" name="Content Placeholder 2">
-            <a:extLst>
-              <a:ext uri="{FF2B5EF4-FFF2-40B4-BE49-F238E27FC236}">
-                <a16:creationId xmlns:a16="http://schemas.microsoft.com/office/drawing/2014/main" id="{C3363ADF-68D6-F673-21C4-C4DED5DFA547}"/>
-              </a:ext>
-            </a:extLst>
-          </p:cNvPr>
-          <p:cNvSpPr>
-            <a:spLocks noGrp="1"/>
-          </p:cNvSpPr>
-          <p:nvPr>
-            <p:ph idx="1"/>
-          </p:nvPr>
-        </p:nvSpPr>
-        <p:spPr/>
-        <p:txBody>
-          <a:bodyPr>
-            <a:normAutofit/>
-          </a:bodyPr>
-          <a:lstStyle/>
-          <a:p>
-            <a:pPr marL="0" indent="0">
-              <a:buNone/>
-            </a:pPr>
-            <a:r>
-              <a:rPr lang="en-US" sz="3600" b="0" i="0" dirty="0">
-                <a:solidFill>
-                  <a:srgbClr val="001D35"/>
-                </a:solidFill>
-                <a:effectLst/>
-                <a:latin typeface="Google Sans"/>
-              </a:rPr>
-              <a:t>Data validation is </a:t>
-            </a:r>
-            <a:r>
-              <a:rPr lang="en-US" sz="3600" dirty="0"/>
-              <a:t>the process of checking and ensuring the accuracy, quality, and consistency of data by verifying that it meets specific criteria, such as correct data types, format, range, and logical consistency, before using it in analysis or processing</a:t>
-            </a:r>
-          </a:p>
-        </p:txBody>
-      </p:sp>
-    </p:spTree>
-    <p:extLst>
-      <p:ext uri="{BB962C8B-B14F-4D97-AF65-F5344CB8AC3E}">
-        <p14:creationId xmlns:p14="http://schemas.microsoft.com/office/powerpoint/2010/main" val="3961884741"/>
-      </p:ext>
-    </p:extLst>
-  </p:cSld>
-  <p:clrMapOvr>
-    <a:masterClrMapping/>
-  </p:clrMapOvr>
-</p:sld>
-</file>
-
 <file path=ppt/slides/slide15.xml><?xml version="1.0" encoding="utf-8"?>
 <p:sld xmlns:a="http://schemas.openxmlformats.org/drawingml/2006/main" xmlns:r="http://schemas.openxmlformats.org/officeDocument/2006/relationships" xmlns:p="http://schemas.openxmlformats.org/presentationml/2006/main">
   <p:cSld>
@@ -3925,6 +3911,114 @@
           <p:cNvPr id="2" name="Title 1">
             <a:extLst>
               <a:ext uri="{FF2B5EF4-FFF2-40B4-BE49-F238E27FC236}">
+                <a16:creationId xmlns:a16="http://schemas.microsoft.com/office/drawing/2014/main" id="{8CBFCD5F-DE8E-6A7C-9FEF-6806621B69CE}"/>
+              </a:ext>
+            </a:extLst>
+          </p:cNvPr>
+          <p:cNvSpPr>
+            <a:spLocks noGrp="1"/>
+          </p:cNvSpPr>
+          <p:nvPr>
+            <p:ph type="title"/>
+          </p:nvPr>
+        </p:nvSpPr>
+        <p:spPr/>
+        <p:txBody>
+          <a:bodyPr/>
+          <a:lstStyle/>
+          <a:p>
+            <a:r>
+              <a:rPr lang="en-US" b="0" i="0" dirty="0">
+                <a:effectLst/>
+                <a:highlight>
+                  <a:srgbClr val="FFFFFF"/>
+                </a:highlight>
+                <a:latin typeface="Roboto" panose="02000000000000000000" pitchFamily="2" charset="0"/>
+              </a:rPr>
+              <a:t>Data Validation</a:t>
+            </a:r>
+            <a:endParaRPr lang="en-US" dirty="0"/>
+          </a:p>
+        </p:txBody>
+      </p:sp>
+      <p:sp>
+        <p:nvSpPr>
+          <p:cNvPr id="3" name="Content Placeholder 2">
+            <a:extLst>
+              <a:ext uri="{FF2B5EF4-FFF2-40B4-BE49-F238E27FC236}">
+                <a16:creationId xmlns:a16="http://schemas.microsoft.com/office/drawing/2014/main" id="{C3363ADF-68D6-F673-21C4-C4DED5DFA547}"/>
+              </a:ext>
+            </a:extLst>
+          </p:cNvPr>
+          <p:cNvSpPr>
+            <a:spLocks noGrp="1"/>
+          </p:cNvSpPr>
+          <p:nvPr>
+            <p:ph idx="1"/>
+          </p:nvPr>
+        </p:nvSpPr>
+        <p:spPr/>
+        <p:txBody>
+          <a:bodyPr>
+            <a:normAutofit/>
+          </a:bodyPr>
+          <a:lstStyle/>
+          <a:p>
+            <a:pPr marL="0" indent="0">
+              <a:buNone/>
+            </a:pPr>
+            <a:r>
+              <a:rPr lang="en-US" sz="3600" b="0" i="0" dirty="0">
+                <a:solidFill>
+                  <a:srgbClr val="001D35"/>
+                </a:solidFill>
+                <a:effectLst/>
+                <a:latin typeface="Google Sans"/>
+              </a:rPr>
+              <a:t>Data validation is </a:t>
+            </a:r>
+            <a:r>
+              <a:rPr lang="en-US" sz="3600" dirty="0"/>
+              <a:t>the process of checking and ensuring the accuracy, quality, and consistency of data by verifying that it meets specific criteria, such as correct data types, format, range, and logical consistency, before using it in analysis or processing</a:t>
+            </a:r>
+          </a:p>
+        </p:txBody>
+      </p:sp>
+    </p:spTree>
+    <p:extLst>
+      <p:ext uri="{BB962C8B-B14F-4D97-AF65-F5344CB8AC3E}">
+        <p14:creationId xmlns:p14="http://schemas.microsoft.com/office/powerpoint/2010/main" val="3961884741"/>
+      </p:ext>
+    </p:extLst>
+  </p:cSld>
+  <p:clrMapOvr>
+    <a:masterClrMapping/>
+  </p:clrMapOvr>
+</p:sld>
+</file>
+
+<file path=ppt/slides/slide16.xml><?xml version="1.0" encoding="utf-8"?>
+<p:sld xmlns:a="http://schemas.openxmlformats.org/drawingml/2006/main" xmlns:r="http://schemas.openxmlformats.org/officeDocument/2006/relationships" xmlns:p="http://schemas.openxmlformats.org/presentationml/2006/main">
+  <p:cSld>
+    <p:spTree>
+      <p:nvGrpSpPr>
+        <p:cNvPr id="1" name=""/>
+        <p:cNvGrpSpPr/>
+        <p:nvPr/>
+      </p:nvGrpSpPr>
+      <p:grpSpPr>
+        <a:xfrm>
+          <a:off x="0" y="0"/>
+          <a:ext cx="0" cy="0"/>
+          <a:chOff x="0" y="0"/>
+          <a:chExt cx="0" cy="0"/>
+        </a:xfrm>
+      </p:grpSpPr>
+      <p:sp>
+        <p:nvSpPr>
+          <p:cNvPr id="2" name="Title 1">
+            <a:extLst>
+              <a:ext uri="{FF2B5EF4-FFF2-40B4-BE49-F238E27FC236}">
                 <a16:creationId xmlns:a16="http://schemas.microsoft.com/office/drawing/2014/main" id="{F927E77E-F1B6-8AF6-FCEF-4A59A0C40ED5}"/>
               </a:ext>
             </a:extLst>
@@ -4042,7 +4136,7 @@
 </p:sld>
 </file>
 
-<file path=ppt/slides/slide16.xml><?xml version="1.0" encoding="utf-8"?>
+<file path=ppt/slides/slide17.xml><?xml version="1.0" encoding="utf-8"?>
 <p:sld xmlns:a="http://schemas.openxmlformats.org/drawingml/2006/main" xmlns:r="http://schemas.openxmlformats.org/officeDocument/2006/relationships" xmlns:p="http://schemas.openxmlformats.org/presentationml/2006/main">
   <p:cSld>
     <p:spTree>
@@ -4138,7 +4232,7 @@
 </p:sld>
 </file>
 
-<file path=ppt/slides/slide17.xml><?xml version="1.0" encoding="utf-8"?>
+<file path=ppt/slides/slide18.xml><?xml version="1.0" encoding="utf-8"?>
 <p:sld xmlns:a="http://schemas.openxmlformats.org/drawingml/2006/main" xmlns:r="http://schemas.openxmlformats.org/officeDocument/2006/relationships" xmlns:p="http://schemas.openxmlformats.org/presentationml/2006/main">
   <p:cSld>
     <p:spTree>
@@ -4225,109 +4319,6 @@
 </p:sld>
 </file>
 
-<file path=ppt/slides/slide18.xml><?xml version="1.0" encoding="utf-8"?>
-<p:sld xmlns:a="http://schemas.openxmlformats.org/drawingml/2006/main" xmlns:r="http://schemas.openxmlformats.org/officeDocument/2006/relationships" xmlns:p="http://schemas.openxmlformats.org/presentationml/2006/main">
-  <p:cSld>
-    <p:spTree>
-      <p:nvGrpSpPr>
-        <p:cNvPr id="1" name=""/>
-        <p:cNvGrpSpPr/>
-        <p:nvPr/>
-      </p:nvGrpSpPr>
-      <p:grpSpPr>
-        <a:xfrm>
-          <a:off x="0" y="0"/>
-          <a:ext cx="0" cy="0"/>
-          <a:chOff x="0" y="0"/>
-          <a:chExt cx="0" cy="0"/>
-        </a:xfrm>
-      </p:grpSpPr>
-      <p:sp>
-        <p:nvSpPr>
-          <p:cNvPr id="2" name="Title 1">
-            <a:extLst>
-              <a:ext uri="{FF2B5EF4-FFF2-40B4-BE49-F238E27FC236}">
-                <a16:creationId xmlns:a16="http://schemas.microsoft.com/office/drawing/2014/main" id="{542026BB-69D0-7220-FB4A-DE83D4A01B25}"/>
-              </a:ext>
-            </a:extLst>
-          </p:cNvPr>
-          <p:cNvSpPr>
-            <a:spLocks noGrp="1"/>
-          </p:cNvSpPr>
-          <p:nvPr>
-            <p:ph type="title"/>
-          </p:nvPr>
-        </p:nvSpPr>
-        <p:spPr/>
-        <p:txBody>
-          <a:bodyPr/>
-          <a:lstStyle/>
-          <a:p>
-            <a:r>
-              <a:rPr lang="en-US" sz="4400" b="1" kern="100" dirty="0">
-                <a:effectLst/>
-                <a:latin typeface="Aptos" panose="020B0004020202020204" pitchFamily="34" charset="0"/>
-                <a:ea typeface="Aptos" panose="020B0004020202020204" pitchFamily="34" charset="0"/>
-                <a:cs typeface="Times New Roman" panose="02020603050405020304" pitchFamily="18" charset="0"/>
-              </a:rPr>
-              <a:t>Why Database instead of App Server?</a:t>
-            </a:r>
-            <a:endParaRPr lang="en-US" dirty="0"/>
-          </a:p>
-        </p:txBody>
-      </p:sp>
-      <p:sp>
-        <p:nvSpPr>
-          <p:cNvPr id="3" name="Content Placeholder 2">
-            <a:extLst>
-              <a:ext uri="{FF2B5EF4-FFF2-40B4-BE49-F238E27FC236}">
-                <a16:creationId xmlns:a16="http://schemas.microsoft.com/office/drawing/2014/main" id="{0C3A792E-DFB2-6277-D807-7ACC42733D70}"/>
-              </a:ext>
-            </a:extLst>
-          </p:cNvPr>
-          <p:cNvSpPr>
-            <a:spLocks noGrp="1"/>
-          </p:cNvSpPr>
-          <p:nvPr>
-            <p:ph idx="1"/>
-          </p:nvPr>
-        </p:nvSpPr>
-        <p:spPr/>
-        <p:txBody>
-          <a:bodyPr>
-            <a:normAutofit/>
-          </a:bodyPr>
-          <a:lstStyle/>
-          <a:p>
-            <a:pPr marL="0" indent="0">
-              <a:buNone/>
-            </a:pPr>
-            <a:r>
-              <a:rPr lang="en-US" sz="2400" dirty="0"/>
-              <a:t>The database should defend itself.  Although both the App Server and Database server are behind the firewall and controlled by the same organization the database is still depending on an external service to defend its data.  By putting validation in the stored procedure the database is defending its own data.</a:t>
-            </a:r>
-          </a:p>
-          <a:p>
-            <a:pPr marL="0" indent="0">
-              <a:buNone/>
-            </a:pPr>
-            <a:endParaRPr lang="en-US" sz="2400" dirty="0"/>
-          </a:p>
-        </p:txBody>
-      </p:sp>
-    </p:spTree>
-    <p:extLst>
-      <p:ext uri="{BB962C8B-B14F-4D97-AF65-F5344CB8AC3E}">
-        <p14:creationId xmlns:p14="http://schemas.microsoft.com/office/powerpoint/2010/main" val="2448862193"/>
-      </p:ext>
-    </p:extLst>
-  </p:cSld>
-  <p:clrMapOvr>
-    <a:masterClrMapping/>
-  </p:clrMapOvr>
-</p:sld>
-</file>
-
 <file path=ppt/slides/slide19.xml><?xml version="1.0" encoding="utf-8"?>
 <p:sld xmlns:a="http://schemas.openxmlformats.org/drawingml/2006/main" xmlns:r="http://schemas.openxmlformats.org/officeDocument/2006/relationships" xmlns:p="http://schemas.openxmlformats.org/presentationml/2006/main">
   <p:cSld>
@@ -4350,7 +4341,7 @@
           <p:cNvPr id="2" name="Title 1">
             <a:extLst>
               <a:ext uri="{FF2B5EF4-FFF2-40B4-BE49-F238E27FC236}">
-                <a16:creationId xmlns:a16="http://schemas.microsoft.com/office/drawing/2014/main" id="{7F9C476B-C0EE-C041-E89E-7D94FCD5476F}"/>
+                <a16:creationId xmlns:a16="http://schemas.microsoft.com/office/drawing/2014/main" id="{542026BB-69D0-7220-FB4A-DE83D4A01B25}"/>
               </a:ext>
             </a:extLst>
           </p:cNvPr>
@@ -4367,120 +4358,61 @@
           <a:lstStyle/>
           <a:p>
             <a:r>
-              <a:rPr lang="en-US" dirty="0"/>
-              <a:t>NEXT</a:t>
-            </a:r>
-          </a:p>
-        </p:txBody>
-      </p:sp>
-      <p:sp>
-        <p:nvSpPr>
-          <p:cNvPr id="3" name="Content Placeholder 2">
-            <a:extLst>
-              <a:ext uri="{FF2B5EF4-FFF2-40B4-BE49-F238E27FC236}">
-                <a16:creationId xmlns:a16="http://schemas.microsoft.com/office/drawing/2014/main" id="{1B1CB9A3-D34E-0FB5-F937-3DB9FBC134EE}"/>
-              </a:ext>
-            </a:extLst>
-          </p:cNvPr>
-          <p:cNvSpPr>
-            <a:spLocks noGrp="1"/>
-          </p:cNvSpPr>
-          <p:nvPr>
-            <p:ph idx="1"/>
-          </p:nvPr>
-        </p:nvSpPr>
-        <p:spPr/>
-        <p:txBody>
-          <a:bodyPr/>
-          <a:lstStyle/>
-          <a:p>
-            <a:pPr marL="0" marR="0" lvl="0" indent="0">
-              <a:spcBef>
-                <a:spcPts val="0"/>
-              </a:spcBef>
-              <a:spcAft>
-                <a:spcPts val="0"/>
-              </a:spcAft>
-              <a:buNone/>
-            </a:pPr>
-            <a:endParaRPr lang="en-US" sz="2800" kern="100" dirty="0">
-              <a:effectLst/>
-              <a:latin typeface="Aptos" panose="020B0004020202020204" pitchFamily="34" charset="0"/>
-              <a:ea typeface="Aptos" panose="020B0004020202020204" pitchFamily="34" charset="0"/>
-              <a:cs typeface="Times New Roman" panose="02020603050405020304" pitchFamily="18" charset="0"/>
-            </a:endParaRPr>
-          </a:p>
-          <a:p>
-            <a:pPr marL="0" marR="0" lvl="0" indent="0">
-              <a:spcBef>
-                <a:spcPts val="0"/>
-              </a:spcBef>
-              <a:spcAft>
-                <a:spcPts val="0"/>
-              </a:spcAft>
-              <a:buNone/>
-            </a:pPr>
-            <a:endParaRPr lang="en-US" sz="2800" kern="100" dirty="0">
-              <a:effectLst/>
-              <a:latin typeface="Aptos" panose="020B0004020202020204" pitchFamily="34" charset="0"/>
-              <a:ea typeface="Aptos" panose="020B0004020202020204" pitchFamily="34" charset="0"/>
-              <a:cs typeface="Times New Roman" panose="02020603050405020304" pitchFamily="18" charset="0"/>
-            </a:endParaRPr>
-          </a:p>
-          <a:p>
-            <a:pPr marL="342900" marR="0" lvl="0" indent="-342900">
-              <a:spcBef>
-                <a:spcPts val="0"/>
-              </a:spcBef>
-              <a:spcAft>
-                <a:spcPts val="0"/>
-              </a:spcAft>
-              <a:buFont typeface="Symbol" pitchFamily="2" charset="2"/>
-              <a:buChar char=""/>
-            </a:pPr>
-            <a:r>
-              <a:rPr lang="en-US" sz="2800" kern="100" dirty="0">
+              <a:rPr lang="en-US" sz="4400" b="1" kern="100" dirty="0">
                 <a:effectLst/>
                 <a:latin typeface="Aptos" panose="020B0004020202020204" pitchFamily="34" charset="0"/>
                 <a:ea typeface="Aptos" panose="020B0004020202020204" pitchFamily="34" charset="0"/>
                 <a:cs typeface="Times New Roman" panose="02020603050405020304" pitchFamily="18" charset="0"/>
               </a:rPr>
-              <a:t>Questions?</a:t>
-            </a:r>
-          </a:p>
-          <a:p>
-            <a:pPr marL="342900" marR="0" lvl="0" indent="-342900">
-              <a:spcBef>
-                <a:spcPts val="0"/>
-              </a:spcBef>
-              <a:spcAft>
-                <a:spcPts val="0"/>
-              </a:spcAft>
-              <a:buFont typeface="Symbol" pitchFamily="2" charset="2"/>
-              <a:buChar char=""/>
+              <a:t>Why Database instead of App Server?</a:t>
+            </a:r>
+            <a:endParaRPr lang="en-US" dirty="0"/>
+          </a:p>
+        </p:txBody>
+      </p:sp>
+      <p:sp>
+        <p:nvSpPr>
+          <p:cNvPr id="3" name="Content Placeholder 2">
+            <a:extLst>
+              <a:ext uri="{FF2B5EF4-FFF2-40B4-BE49-F238E27FC236}">
+                <a16:creationId xmlns:a16="http://schemas.microsoft.com/office/drawing/2014/main" id="{0C3A792E-DFB2-6277-D807-7ACC42733D70}"/>
+              </a:ext>
+            </a:extLst>
+          </p:cNvPr>
+          <p:cNvSpPr>
+            <a:spLocks noGrp="1"/>
+          </p:cNvSpPr>
+          <p:nvPr>
+            <p:ph idx="1"/>
+          </p:nvPr>
+        </p:nvSpPr>
+        <p:spPr/>
+        <p:txBody>
+          <a:bodyPr>
+            <a:normAutofit/>
+          </a:bodyPr>
+          <a:lstStyle/>
+          <a:p>
+            <a:pPr marL="0" indent="0">
+              <a:buNone/>
             </a:pPr>
             <a:r>
-              <a:rPr lang="en-US" kern="100" dirty="0" err="1">
-                <a:effectLst/>
-                <a:latin typeface="Aptos" panose="020B0004020202020204" pitchFamily="34" charset="0"/>
-                <a:ea typeface="Aptos" panose="020B0004020202020204" pitchFamily="34" charset="0"/>
-                <a:cs typeface="Times New Roman" panose="02020603050405020304" pitchFamily="18" charset="0"/>
-              </a:rPr>
-              <a:t>www.appjedi.net</a:t>
-            </a:r>
-            <a:endParaRPr lang="en-US" sz="2800" kern="100" dirty="0">
-              <a:effectLst/>
-              <a:latin typeface="Aptos" panose="020B0004020202020204" pitchFamily="34" charset="0"/>
-              <a:ea typeface="Aptos" panose="020B0004020202020204" pitchFamily="34" charset="0"/>
-              <a:cs typeface="Times New Roman" panose="02020603050405020304" pitchFamily="18" charset="0"/>
-            </a:endParaRPr>
+              <a:rPr lang="en-US" sz="2400" dirty="0"/>
+              <a:t>The database should defend itself.  Although both the App Server and Database server are behind the firewall and controlled by the same organization the database is still depending on an external service to defend its data.  By putting validation in the stored procedure the database is defending its own data.</a:t>
+            </a:r>
+          </a:p>
+          <a:p>
+            <a:pPr marL="0" indent="0">
+              <a:buNone/>
+            </a:pPr>
+            <a:endParaRPr lang="en-US" sz="2400" dirty="0"/>
           </a:p>
         </p:txBody>
       </p:sp>
     </p:spTree>
     <p:extLst>
       <p:ext uri="{BB962C8B-B14F-4D97-AF65-F5344CB8AC3E}">
-        <p14:creationId xmlns:p14="http://schemas.microsoft.com/office/powerpoint/2010/main" val="404810066"/>
+        <p14:creationId xmlns:p14="http://schemas.microsoft.com/office/powerpoint/2010/main" val="2448862193"/>
       </p:ext>
     </p:extLst>
   </p:cSld>
@@ -4601,6 +4533,168 @@
     <p:extLst>
       <p:ext uri="{BB962C8B-B14F-4D97-AF65-F5344CB8AC3E}">
         <p14:creationId xmlns:p14="http://schemas.microsoft.com/office/powerpoint/2010/main" val="3195505390"/>
+      </p:ext>
+    </p:extLst>
+  </p:cSld>
+  <p:clrMapOvr>
+    <a:masterClrMapping/>
+  </p:clrMapOvr>
+</p:sld>
+</file>
+
+<file path=ppt/slides/slide20.xml><?xml version="1.0" encoding="utf-8"?>
+<p:sld xmlns:a="http://schemas.openxmlformats.org/drawingml/2006/main" xmlns:r="http://schemas.openxmlformats.org/officeDocument/2006/relationships" xmlns:p="http://schemas.openxmlformats.org/presentationml/2006/main">
+  <p:cSld>
+    <p:spTree>
+      <p:nvGrpSpPr>
+        <p:cNvPr id="1" name=""/>
+        <p:cNvGrpSpPr/>
+        <p:nvPr/>
+      </p:nvGrpSpPr>
+      <p:grpSpPr>
+        <a:xfrm>
+          <a:off x="0" y="0"/>
+          <a:ext cx="0" cy="0"/>
+          <a:chOff x="0" y="0"/>
+          <a:chExt cx="0" cy="0"/>
+        </a:xfrm>
+      </p:grpSpPr>
+      <p:sp>
+        <p:nvSpPr>
+          <p:cNvPr id="2" name="Title 1">
+            <a:extLst>
+              <a:ext uri="{FF2B5EF4-FFF2-40B4-BE49-F238E27FC236}">
+                <a16:creationId xmlns:a16="http://schemas.microsoft.com/office/drawing/2014/main" id="{7F9C476B-C0EE-C041-E89E-7D94FCD5476F}"/>
+              </a:ext>
+            </a:extLst>
+          </p:cNvPr>
+          <p:cNvSpPr>
+            <a:spLocks noGrp="1"/>
+          </p:cNvSpPr>
+          <p:nvPr>
+            <p:ph type="title"/>
+          </p:nvPr>
+        </p:nvSpPr>
+        <p:spPr/>
+        <p:txBody>
+          <a:bodyPr/>
+          <a:lstStyle/>
+          <a:p>
+            <a:r>
+              <a:rPr lang="en-US" dirty="0"/>
+              <a:t>NEXT</a:t>
+            </a:r>
+          </a:p>
+        </p:txBody>
+      </p:sp>
+      <p:sp>
+        <p:nvSpPr>
+          <p:cNvPr id="3" name="Content Placeholder 2">
+            <a:extLst>
+              <a:ext uri="{FF2B5EF4-FFF2-40B4-BE49-F238E27FC236}">
+                <a16:creationId xmlns:a16="http://schemas.microsoft.com/office/drawing/2014/main" id="{1B1CB9A3-D34E-0FB5-F937-3DB9FBC134EE}"/>
+              </a:ext>
+            </a:extLst>
+          </p:cNvPr>
+          <p:cNvSpPr>
+            <a:spLocks noGrp="1"/>
+          </p:cNvSpPr>
+          <p:nvPr>
+            <p:ph idx="1"/>
+          </p:nvPr>
+        </p:nvSpPr>
+        <p:spPr/>
+        <p:txBody>
+          <a:bodyPr/>
+          <a:lstStyle/>
+          <a:p>
+            <a:pPr marL="0" marR="0" lvl="0" indent="0">
+              <a:spcBef>
+                <a:spcPts val="0"/>
+              </a:spcBef>
+              <a:spcAft>
+                <a:spcPts val="0"/>
+              </a:spcAft>
+              <a:buNone/>
+            </a:pPr>
+            <a:endParaRPr lang="en-US" sz="2800" kern="100" dirty="0">
+              <a:effectLst/>
+              <a:latin typeface="Aptos" panose="020B0004020202020204" pitchFamily="34" charset="0"/>
+              <a:ea typeface="Aptos" panose="020B0004020202020204" pitchFamily="34" charset="0"/>
+              <a:cs typeface="Times New Roman" panose="02020603050405020304" pitchFamily="18" charset="0"/>
+            </a:endParaRPr>
+          </a:p>
+          <a:p>
+            <a:pPr marL="0" marR="0" lvl="0" indent="0">
+              <a:spcBef>
+                <a:spcPts val="0"/>
+              </a:spcBef>
+              <a:spcAft>
+                <a:spcPts val="0"/>
+              </a:spcAft>
+              <a:buNone/>
+            </a:pPr>
+            <a:endParaRPr lang="en-US" sz="2800" kern="100" dirty="0">
+              <a:effectLst/>
+              <a:latin typeface="Aptos" panose="020B0004020202020204" pitchFamily="34" charset="0"/>
+              <a:ea typeface="Aptos" panose="020B0004020202020204" pitchFamily="34" charset="0"/>
+              <a:cs typeface="Times New Roman" panose="02020603050405020304" pitchFamily="18" charset="0"/>
+            </a:endParaRPr>
+          </a:p>
+          <a:p>
+            <a:pPr marL="342900" marR="0" lvl="0" indent="-342900">
+              <a:spcBef>
+                <a:spcPts val="0"/>
+              </a:spcBef>
+              <a:spcAft>
+                <a:spcPts val="0"/>
+              </a:spcAft>
+              <a:buFont typeface="Symbol" pitchFamily="2" charset="2"/>
+              <a:buChar char=""/>
+            </a:pPr>
+            <a:r>
+              <a:rPr lang="en-US" sz="2800" kern="100" dirty="0">
+                <a:effectLst/>
+                <a:latin typeface="Aptos" panose="020B0004020202020204" pitchFamily="34" charset="0"/>
+                <a:ea typeface="Aptos" panose="020B0004020202020204" pitchFamily="34" charset="0"/>
+                <a:cs typeface="Times New Roman" panose="02020603050405020304" pitchFamily="18" charset="0"/>
+              </a:rPr>
+              <a:t>Questions?</a:t>
+            </a:r>
+          </a:p>
+          <a:p>
+            <a:pPr marL="342900" marR="0" lvl="0" indent="-342900">
+              <a:spcBef>
+                <a:spcPts val="0"/>
+              </a:spcBef>
+              <a:spcAft>
+                <a:spcPts val="0"/>
+              </a:spcAft>
+              <a:buFont typeface="Symbol" pitchFamily="2" charset="2"/>
+              <a:buChar char=""/>
+            </a:pPr>
+            <a:r>
+              <a:rPr lang="en-US" kern="100" dirty="0" err="1">
+                <a:effectLst/>
+                <a:latin typeface="Aptos" panose="020B0004020202020204" pitchFamily="34" charset="0"/>
+                <a:ea typeface="Aptos" panose="020B0004020202020204" pitchFamily="34" charset="0"/>
+                <a:cs typeface="Times New Roman" panose="02020603050405020304" pitchFamily="18" charset="0"/>
+              </a:rPr>
+              <a:t>www.appjedi.net</a:t>
+            </a:r>
+            <a:endParaRPr lang="en-US" sz="2800" kern="100" dirty="0">
+              <a:effectLst/>
+              <a:latin typeface="Aptos" panose="020B0004020202020204" pitchFamily="34" charset="0"/>
+              <a:ea typeface="Aptos" panose="020B0004020202020204" pitchFamily="34" charset="0"/>
+              <a:cs typeface="Times New Roman" panose="02020603050405020304" pitchFamily="18" charset="0"/>
+            </a:endParaRPr>
+          </a:p>
+        </p:txBody>
+      </p:sp>
+    </p:spTree>
+    <p:extLst>
+      <p:ext uri="{BB962C8B-B14F-4D97-AF65-F5344CB8AC3E}">
+        <p14:creationId xmlns:p14="http://schemas.microsoft.com/office/powerpoint/2010/main" val="404810066"/>
       </p:ext>
     </p:extLst>
   </p:cSld>
@@ -4809,6 +4903,103 @@
           <p:cNvPr id="2" name="Title 1">
             <a:extLst>
               <a:ext uri="{FF2B5EF4-FFF2-40B4-BE49-F238E27FC236}">
+                <a16:creationId xmlns:a16="http://schemas.microsoft.com/office/drawing/2014/main" id="{EDCFE6C6-759A-7807-927C-779FE4605271}"/>
+              </a:ext>
+            </a:extLst>
+          </p:cNvPr>
+          <p:cNvSpPr>
+            <a:spLocks noGrp="1"/>
+          </p:cNvSpPr>
+          <p:nvPr>
+            <p:ph type="title"/>
+          </p:nvPr>
+        </p:nvSpPr>
+        <p:spPr>
+          <a:xfrm>
+            <a:off x="838200" y="365125"/>
+            <a:ext cx="10515600" cy="689952"/>
+          </a:xfrm>
+        </p:spPr>
+        <p:txBody>
+          <a:bodyPr>
+            <a:normAutofit fontScale="90000"/>
+          </a:bodyPr>
+          <a:lstStyle/>
+          <a:p>
+            <a:r>
+              <a:rPr lang="en-US" dirty="0"/>
+              <a:t>Benefits:</a:t>
+            </a:r>
+          </a:p>
+        </p:txBody>
+      </p:sp>
+      <p:pic>
+        <p:nvPicPr>
+          <p:cNvPr id="5" name="Content Placeholder 4">
+            <a:extLst>
+              <a:ext uri="{FF2B5EF4-FFF2-40B4-BE49-F238E27FC236}">
+                <a16:creationId xmlns:a16="http://schemas.microsoft.com/office/drawing/2014/main" id="{BA1E140E-EE5B-E2F2-5243-EF03A836AB9F}"/>
+              </a:ext>
+            </a:extLst>
+          </p:cNvPr>
+          <p:cNvPicPr>
+            <a:picLocks noGrp="1" noChangeAspect="1"/>
+          </p:cNvPicPr>
+          <p:nvPr>
+            <p:ph idx="1"/>
+          </p:nvPr>
+        </p:nvPicPr>
+        <p:blipFill>
+          <a:blip r:embed="rId2"/>
+          <a:stretch>
+            <a:fillRect/>
+          </a:stretch>
+        </p:blipFill>
+        <p:spPr>
+          <a:xfrm>
+            <a:off x="1186962" y="1336431"/>
+            <a:ext cx="7262953" cy="4930737"/>
+          </a:xfrm>
+          <a:prstGeom prst="rect">
+            <a:avLst/>
+          </a:prstGeom>
+        </p:spPr>
+      </p:pic>
+    </p:spTree>
+    <p:extLst>
+      <p:ext uri="{BB962C8B-B14F-4D97-AF65-F5344CB8AC3E}">
+        <p14:creationId xmlns:p14="http://schemas.microsoft.com/office/powerpoint/2010/main" val="1086174292"/>
+      </p:ext>
+    </p:extLst>
+  </p:cSld>
+  <p:clrMapOvr>
+    <a:masterClrMapping/>
+  </p:clrMapOvr>
+</p:sld>
+</file>
+
+<file path=ppt/slides/slide6.xml><?xml version="1.0" encoding="utf-8"?>
+<p:sld xmlns:a="http://schemas.openxmlformats.org/drawingml/2006/main" xmlns:r="http://schemas.openxmlformats.org/officeDocument/2006/relationships" xmlns:p="http://schemas.openxmlformats.org/presentationml/2006/main">
+  <p:cSld>
+    <p:spTree>
+      <p:nvGrpSpPr>
+        <p:cNvPr id="1" name=""/>
+        <p:cNvGrpSpPr/>
+        <p:nvPr/>
+      </p:nvGrpSpPr>
+      <p:grpSpPr>
+        <a:xfrm>
+          <a:off x="0" y="0"/>
+          <a:ext cx="0" cy="0"/>
+          <a:chOff x="0" y="0"/>
+          <a:chExt cx="0" cy="0"/>
+        </a:xfrm>
+      </p:grpSpPr>
+      <p:sp>
+        <p:nvSpPr>
+          <p:cNvPr id="2" name="Title 1">
+            <a:extLst>
+              <a:ext uri="{FF2B5EF4-FFF2-40B4-BE49-F238E27FC236}">
                 <a16:creationId xmlns:a16="http://schemas.microsoft.com/office/drawing/2014/main" id="{F927E77E-F1B6-8AF6-FCEF-4A59A0C40ED5}"/>
               </a:ext>
             </a:extLst>
@@ -4884,7 +5075,7 @@
 </p:sld>
 </file>
 
-<file path=ppt/slides/slide6.xml><?xml version="1.0" encoding="utf-8"?>
+<file path=ppt/slides/slide7.xml><?xml version="1.0" encoding="utf-8"?>
 <p:sld xmlns:a="http://schemas.openxmlformats.org/drawingml/2006/main" xmlns:r="http://schemas.openxmlformats.org/officeDocument/2006/relationships" xmlns:p="http://schemas.openxmlformats.org/presentationml/2006/main">
   <p:cSld>
     <p:spTree>
@@ -5197,7 +5388,7 @@
 </p:sld>
 </file>
 
-<file path=ppt/slides/slide7.xml><?xml version="1.0" encoding="utf-8"?>
+<file path=ppt/slides/slide8.xml><?xml version="1.0" encoding="utf-8"?>
 <p:sld xmlns:a="http://schemas.openxmlformats.org/drawingml/2006/main" xmlns:r="http://schemas.openxmlformats.org/officeDocument/2006/relationships" xmlns:p="http://schemas.openxmlformats.org/presentationml/2006/main">
   <p:cSld>
     <p:spTree>
@@ -5321,7 +5512,7 @@
 </p:sld>
 </file>
 
-<file path=ppt/slides/slide8.xml><?xml version="1.0" encoding="utf-8"?>
+<file path=ppt/slides/slide9.xml><?xml version="1.0" encoding="utf-8"?>
 <p:sld xmlns:a="http://schemas.openxmlformats.org/drawingml/2006/main" xmlns:r="http://schemas.openxmlformats.org/officeDocument/2006/relationships" xmlns:p="http://schemas.openxmlformats.org/presentationml/2006/main">
   <p:cSld>
     <p:spTree>
@@ -5432,100 +5623,6 @@
     <p:extLst>
       <p:ext uri="{BB962C8B-B14F-4D97-AF65-F5344CB8AC3E}">
         <p14:creationId xmlns:p14="http://schemas.microsoft.com/office/powerpoint/2010/main" val="1219565982"/>
-      </p:ext>
-    </p:extLst>
-  </p:cSld>
-  <p:clrMapOvr>
-    <a:masterClrMapping/>
-  </p:clrMapOvr>
-</p:sld>
-</file>
-
-<file path=ppt/slides/slide9.xml><?xml version="1.0" encoding="utf-8"?>
-<p:sld xmlns:a="http://schemas.openxmlformats.org/drawingml/2006/main" xmlns:r="http://schemas.openxmlformats.org/officeDocument/2006/relationships" xmlns:p="http://schemas.openxmlformats.org/presentationml/2006/main">
-  <p:cSld>
-    <p:spTree>
-      <p:nvGrpSpPr>
-        <p:cNvPr id="1" name=""/>
-        <p:cNvGrpSpPr/>
-        <p:nvPr/>
-      </p:nvGrpSpPr>
-      <p:grpSpPr>
-        <a:xfrm>
-          <a:off x="0" y="0"/>
-          <a:ext cx="0" cy="0"/>
-          <a:chOff x="0" y="0"/>
-          <a:chExt cx="0" cy="0"/>
-        </a:xfrm>
-      </p:grpSpPr>
-      <p:sp>
-        <p:nvSpPr>
-          <p:cNvPr id="2" name="Title 1">
-            <a:extLst>
-              <a:ext uri="{FF2B5EF4-FFF2-40B4-BE49-F238E27FC236}">
-                <a16:creationId xmlns:a16="http://schemas.microsoft.com/office/drawing/2014/main" id="{584F92C9-1DAE-04AF-D8A8-4890FC19A0FE}"/>
-              </a:ext>
-            </a:extLst>
-          </p:cNvPr>
-          <p:cNvSpPr>
-            <a:spLocks noGrp="1"/>
-          </p:cNvSpPr>
-          <p:nvPr>
-            <p:ph type="title"/>
-          </p:nvPr>
-        </p:nvSpPr>
-        <p:spPr/>
-        <p:txBody>
-          <a:bodyPr/>
-          <a:lstStyle/>
-          <a:p>
-            <a:r>
-              <a:rPr lang="en-US" b="0" i="0" dirty="0">
-                <a:effectLst/>
-                <a:highlight>
-                  <a:srgbClr val="FFFFFF"/>
-                </a:highlight>
-                <a:latin typeface="Roboto" panose="02000000000000000000" pitchFamily="2" charset="0"/>
-              </a:rPr>
-              <a:t>Service layer:</a:t>
-            </a:r>
-            <a:endParaRPr lang="en-US" dirty="0"/>
-          </a:p>
-        </p:txBody>
-      </p:sp>
-      <p:pic>
-        <p:nvPicPr>
-          <p:cNvPr id="5" name="Content Placeholder 4" descr="A computer screen shot of text&#10;&#10;AI-generated content may be incorrect.">
-            <a:extLst>
-              <a:ext uri="{FF2B5EF4-FFF2-40B4-BE49-F238E27FC236}">
-                <a16:creationId xmlns:a16="http://schemas.microsoft.com/office/drawing/2014/main" id="{BA4A2944-7BEA-BF5E-C4C4-013128DE48B0}"/>
-              </a:ext>
-            </a:extLst>
-          </p:cNvPr>
-          <p:cNvPicPr>
-            <a:picLocks noGrp="1" noChangeAspect="1"/>
-          </p:cNvPicPr>
-          <p:nvPr>
-            <p:ph idx="1"/>
-          </p:nvPr>
-        </p:nvPicPr>
-        <p:blipFill>
-          <a:blip r:embed="rId2"/>
-          <a:stretch>
-            <a:fillRect/>
-          </a:stretch>
-        </p:blipFill>
-        <p:spPr>
-          <a:xfrm>
-            <a:off x="2870200" y="1981994"/>
-            <a:ext cx="6451600" cy="4038600"/>
-          </a:xfrm>
-        </p:spPr>
-      </p:pic>
-    </p:spTree>
-    <p:extLst>
-      <p:ext uri="{BB962C8B-B14F-4D97-AF65-F5344CB8AC3E}">
-        <p14:creationId xmlns:p14="http://schemas.microsoft.com/office/powerpoint/2010/main" val="2099651633"/>
       </p:ext>
     </p:extLst>
   </p:cSld>

</xml_diff>